<commit_message>
feat: promote leak-probe TF-IDF model to first-class baseline; honest redaction scope
Adversarial recheck found the window-trained probe (92.2%/73.3%) was the
strongest injury predictor in the repo but lived only in the leak-audit
file. It now runs as tfidf_lr_baseline_heldout.py on the identical
cohort with per-item logging, enters the significance report as a fifth
primary Holm comparison (bn-sev ties it: p=0.87 injury / 0.29 damage),
and appears in every results table. Redaction claims corrected to
"removes explicit outcome statements, not outcome predictability", the
false "held-out touched only once" sentence replaced with a disclosed
test-set-reuse limitation, and the 1,742-vs-1,286 training-count prose
error fixed.

Co-authored-by: Cursor <cursoragent@cursor.com>
</commit_message>
<xml_diff>
--- a/Frozen-BN-Narrative-Evidence-2026-07-20/presentations_FrozenBN/maha_jul31_update.pptx
+++ b/Frozen-BN-Narrative-Evidence-2026-07-20/presentations_FrozenBN/maha_jul31_update.pptx
@@ -10850,7 +10850,7 @@
                             <a:srgbClr val="000000"/>
                           </a:solidFill>
                         </a:rPr>
-                        <a:t>Table 7 cause distribution</a:t>
+                        <a:t>Table 7 cause distribution (published)</a:t>
                       </a:r>
                     </a:p>
                   </a:txBody>
@@ -10867,7 +10867,7 @@
                             <a:srgbClr val="000000"/>
                           </a:solidFill>
                         </a:rPr>
-                        <a:t>113 entries</a:t>
+                        <a:t>85 rows</a:t>
                       </a:r>
                     </a:p>
                   </a:txBody>
@@ -10884,7 +10884,7 @@
                             <a:srgbClr val="000000"/>
                           </a:solidFill>
                         </a:rPr>
-                        <a:t>113/113</a:t>
+                        <a:t>85/85</a:t>
                       </a:r>
                     </a:p>
                   </a:txBody>
@@ -11045,7 +11045,7 @@
         </p:nvGraphicFramePr>
         <p:xfrm>
           <a:off x="822960" y="1965960"/>
-          <a:ext cx="10424160" cy="2377440"/>
+          <a:ext cx="10424160" cy="2651760"/>
         </p:xfrm>
         <a:graphic>
           <a:graphicData uri="http://schemas.openxmlformats.org/drawingml/2006/table">
@@ -11058,7 +11058,7 @@
                 <a:gridCol w="1828800"/>
                 <a:gridCol w="1828800"/>
               </a:tblGrid>
-              <a:tr h="475488">
+              <a:tr h="441960">
                 <a:tc>
                   <a:txBody>
                     <a:bodyPr/>
@@ -11111,7 +11111,7 @@
                   <a:tcPr/>
                 </a:tc>
               </a:tr>
-              <a:tr h="475488">
+              <a:tr h="441960">
                 <a:tc>
                   <a:txBody>
                     <a:bodyPr/>
@@ -11164,7 +11164,7 @@
                   <a:tcPr/>
                 </a:tc>
               </a:tr>
-              <a:tr h="475488">
+              <a:tr h="441960">
                 <a:tc>
                   <a:txBody>
                     <a:bodyPr/>
@@ -11193,7 +11193,7 @@
                             <a:srgbClr val="000000"/>
                           </a:solidFill>
                         </a:rPr>
-                        <a:t>82.1%</a:t>
+                        <a:t>82.4%</a:t>
                       </a:r>
                     </a:p>
                   </a:txBody>
@@ -11217,7 +11217,7 @@
                   <a:tcPr/>
                 </a:tc>
               </a:tr>
-              <a:tr h="475488">
+              <a:tr h="441960">
                 <a:tc>
                   <a:txBody>
                     <a:bodyPr/>
@@ -11270,7 +11270,7 @@
                   <a:tcPr/>
                 </a:tc>
               </a:tr>
-              <a:tr h="475488">
+              <a:tr h="441960">
                 <a:tc>
                   <a:txBody>
                     <a:bodyPr/>
@@ -11282,7 +11282,7 @@
                             <a:srgbClr val="000000"/>
                           </a:solidFill>
                         </a:rPr>
-                        <a:t>Trained model on the same text (comparison)</a:t>
+                        <a:t>Trained embedding model (comparison)</a:t>
                       </a:r>
                     </a:p>
                   </a:txBody>
@@ -11323,6 +11323,59 @@
                   <a:tcPr/>
                 </a:tc>
               </a:tr>
+              <a:tr h="441960">
+                <a:tc>
+                  <a:txBody>
+                    <a:bodyPr/>
+                    <a:lstStyle/>
+                    <a:p>
+                      <a:r>
+                        <a:rPr sz="1400">
+                          <a:solidFill>
+                            <a:srgbClr val="000000"/>
+                          </a:solidFill>
+                        </a:rPr>
+                        <a:t>Trained word-frequency model (comparison)</a:t>
+                      </a:r>
+                    </a:p>
+                  </a:txBody>
+                  <a:tcPr/>
+                </a:tc>
+                <a:tc>
+                  <a:txBody>
+                    <a:bodyPr/>
+                    <a:lstStyle/>
+                    <a:p>
+                      <a:r>
+                        <a:rPr sz="1400">
+                          <a:solidFill>
+                            <a:srgbClr val="000000"/>
+                          </a:solidFill>
+                        </a:rPr>
+                        <a:t>92.2%</a:t>
+                      </a:r>
+                    </a:p>
+                  </a:txBody>
+                  <a:tcPr/>
+                </a:tc>
+                <a:tc>
+                  <a:txBody>
+                    <a:bodyPr/>
+                    <a:lstStyle/>
+                    <a:p>
+                      <a:r>
+                        <a:rPr sz="1400">
+                          <a:solidFill>
+                            <a:srgbClr val="000000"/>
+                          </a:solidFill>
+                        </a:rPr>
+                        <a:t>73.3%</a:t>
+                      </a:r>
+                    </a:p>
+                  </a:txBody>
+                  <a:tcPr/>
+                </a:tc>
+              </a:tr>
             </a:tbl>
           </a:graphicData>
         </a:graphic>
@@ -11335,7 +11388,7 @@
         </p:nvSpPr>
         <p:spPr>
           <a:xfrm>
-            <a:off x="822960" y="4709160"/>
+            <a:off x="822960" y="4892040"/>
             <a:ext cx="10515600" cy="777240"/>
           </a:xfrm>
           <a:prstGeom prst="rect">
@@ -11351,7 +11404,7 @@
           <a:p>
             <a:r>
               <a:rPr sz="1400" b="1"/>
-              <a:t>Outcome sentences are stripped before prediction — the honest numbers (93/81 was pre-fix). Tie with the trained model on injury; stronger on severe damage.</a:t>
+              <a:t>Outcome sentences are stripped before ANY use of the text — the honest numbers (93/81 was pre-fix). Statistical ties with both trained models; stronger on severe damage — and zero training.</a:t>
             </a:r>
           </a:p>
         </p:txBody>

</xml_diff>

<commit_message>
fix: first-author adjudication of 75-row mapping audit; 2 rules corrected, eval rerun (retrieval 83.8->84.2)
Co-authored-by: Cursor <cursoragent@cursor.com>
</commit_message>
<xml_diff>
--- a/Frozen-BN-Narrative-Evidence-2026-07-20/presentations_FrozenBN/maha_jul31_update.pptx
+++ b/Frozen-BN-Narrative-Evidence-2026-07-20/presentations_FrozenBN/maha_jul31_update.pptx
@@ -11811,7 +11811,7 @@
                             <a:srgbClr val="000000"/>
                           </a:solidFill>
                         </a:rPr>
-                        <a:t>83.8%</a:t>
+                        <a:t>84.2%</a:t>
                       </a:r>
                     </a:p>
                   </a:txBody>
@@ -11828,7 +11828,7 @@
                             <a:srgbClr val="000000"/>
                           </a:solidFill>
                         </a:rPr>
-                        <a:t>0.912</a:t>
+                        <a:t>0.915</a:t>
                       </a:r>
                     </a:p>
                   </a:txBody>
@@ -11916,7 +11916,7 @@
           <a:p>
             <a:r>
               <a:rPr sz="1400" b="1"/>
-              <a:t>Balanced across Personnel/Aircraft/Environment (68/62/72% recall). Disclosed: trained model +4 pts (p=0.03); nobody catches the rare Organizational class.</a:t>
+              <a:t>Balanced across Personnel/Aircraft/Environment (68/62/72% recall). Disclosed: trained model +4 pts (p=0.04); nobody catches the rare Organizational class.</a:t>
             </a:r>
           </a:p>
         </p:txBody>

</xml_diff>